<commit_message>
docs(pptx): slides toevoegen voor GitHub-synchronisatie en PDF-generatie
Co-Authored-By: Claude Sonnet 4.6 <noreply@anthropic.com>
</commit_message>
<xml_diff>
--- a/Blauwdrukbeheer-demo.pptx
+++ b/Blauwdrukbeheer-demo.pptx
@@ -5,7 +5,7 @@
     <p:sldMasterId id="2147483648" r:id="rId1"/>
   </p:sldMasterIdLst>
   <p:notesMasterIdLst>
-    <p:notesMasterId r:id="rId11"/>
+    <p:notesMasterId r:id="rId13"/>
   </p:notesMasterIdLst>
   <p:sldIdLst>
     <p:sldId id="256" r:id="rId2"/>
@@ -16,7 +16,9 @@
     <p:sldId id="264" r:id="rId7"/>
     <p:sldId id="261" r:id="rId8"/>
     <p:sldId id="262" r:id="rId9"/>
-    <p:sldId id="263" r:id="rId10"/>
+    <p:sldId id="265" r:id="rId10"/>
+    <p:sldId id="266" r:id="rId11"/>
+    <p:sldId id="263" r:id="rId12"/>
   </p:sldIdLst>
   <p:sldSz cx="9144000" cy="5143500" type="screen16x9"/>
   <p:notesSz cx="5143500" cy="9144000"/>
@@ -1006,7 +1008,7 @@
           <a:p>
             <a:fld id="{F7021451-1387-4CA6-816F-3879F97B5CBC}" type="slidenum">
               <a:rPr lang="en-US"/>
-              <a:t>9</a:t>
+              <a:t>11</a:t>
             </a:fld>
             <a:endParaRPr lang="en-US"/>
           </a:p>
@@ -1660,6 +1662,774 @@
 </p:sld>
 </file>
 
+<file path=ppt/slides/slide10.xml><?xml version="1.0" encoding="utf-8"?>
+<p:sld xmlns:a="http://schemas.openxmlformats.org/drawingml/2006/main" xmlns:r="http://schemas.openxmlformats.org/officeDocument/2006/relationships" xmlns:p="http://schemas.openxmlformats.org/presentationml/2006/main">
+  <p:cSld name="Slide 11">
+    <p:bg>
+      <p:bgPr>
+        <a:solidFill>
+          <a:srgbClr val="F1F5F9"/>
+        </a:solidFill>
+        <a:effectLst/>
+      </p:bgPr>
+    </p:bg>
+    <p:spTree>
+      <p:nvGrpSpPr>
+        <p:cNvPr id="1" name=""/>
+        <p:cNvGrpSpPr/>
+        <p:nvPr/>
+      </p:nvGrpSpPr>
+      <p:grpSpPr>
+        <a:xfrm>
+          <a:off x="0" y="0"/>
+          <a:ext cx="0" cy="0"/>
+          <a:chOff x="0" y="0"/>
+          <a:chExt cx="0" cy="0"/>
+        </a:xfrm>
+      </p:grpSpPr>
+      <p:sp>
+        <p:nvSpPr>
+          <p:cNvPr id="2" name="Text 0"/>
+          <p:cNvSpPr/>
+          <p:nvPr/>
+        </p:nvSpPr>
+        <p:spPr>
+          <a:xfrm>
+            <a:off x="457200" y="274320"/>
+            <a:ext cx="8229600" cy="502920"/>
+          </a:xfrm>
+          <a:prstGeom prst="rect">
+            <a:avLst/>
+          </a:prstGeom>
+          <a:noFill/>
+          <a:ln/>
+        </p:spPr>
+        <p:txBody>
+          <a:bodyPr wrap="square" lIns="0" tIns="0" rIns="0" bIns="0" rtlCol="0" anchor="ctr"/>
+          <a:lstStyle/>
+          <a:p>
+            <a:pPr marL="0" indent="0" algn="l">
+              <a:buNone/>
+            </a:pPr>
+            <a:r>
+              <a:rPr lang="nl-NL" sz="2600" b="1" dirty="0">
+                <a:solidFill>
+                  <a:srgbClr val="1E293B"/>
+                </a:solidFill>
+                <a:latin typeface="Arial Black" pitchFamily="34" charset="0"/>
+                <a:ea typeface="Arial Black" pitchFamily="34" charset="-122"/>
+                <a:cs typeface="Arial Black" pitchFamily="34" charset="-120"/>
+              </a:rPr>
+              <a:t>PDF-generatie</a:t>
+            </a:r>
+            <a:endParaRPr lang="nl-NL" sz="2600" dirty="0"/>
+          </a:p>
+        </p:txBody>
+      </p:sp>
+      <p:sp>
+        <p:nvSpPr>
+          <p:cNvPr id="3" name="Text 1"/>
+          <p:cNvSpPr/>
+          <p:nvPr/>
+        </p:nvSpPr>
+        <p:spPr>
+          <a:xfrm>
+            <a:off x="457200" y="822960"/>
+            <a:ext cx="8229600" cy="365760"/>
+          </a:xfrm>
+          <a:prstGeom prst="rect">
+            <a:avLst/>
+          </a:prstGeom>
+          <a:noFill/>
+          <a:ln/>
+        </p:spPr>
+        <p:txBody>
+          <a:bodyPr wrap="square" lIns="0" tIns="0" rIns="0" bIns="0" rtlCol="0" anchor="ctr"/>
+          <a:lstStyle/>
+          <a:p>
+            <a:pPr marL="0" indent="0" algn="l">
+              <a:buNone/>
+            </a:pPr>
+            <a:r>
+              <a:rPr lang="nl-NL" sz="1200" dirty="0">
+                <a:solidFill>
+                  <a:srgbClr val="475569"/>
+                </a:solidFill>
+                <a:latin typeface="Calibri" pitchFamily="34" charset="0"/>
+                <a:ea typeface="Calibri" pitchFamily="34" charset="-122"/>
+                <a:cs typeface="Calibri" pitchFamily="34" charset="-120"/>
+              </a:rPr>
+              <a:t>Modulebeschrijvingen worden volledig in de browser gegenereerd (html2canvas + jsPDF) en als PDF meegecommit in dezelfde pull request als de JSON-bestanden.</a:t>
+            </a:r>
+            <a:endParaRPr lang="nl-NL" sz="1200" dirty="0"/>
+          </a:p>
+        </p:txBody>
+      </p:sp>
+      <p:pic>
+        <p:nvPicPr>
+          <p:cNvPr id="6" name="Picture 5">
+            <a:extLst>
+              <a:ext uri="{FF2B5EF4-FFF2-40B4-BE49-F238E27FC236}">
+                <a16:creationId xmlns:a16="http://schemas.microsoft.com/office/drawing/2014/main" id="{1396172B-2296-9D1C-F202-C8213AEE2EBE}"/>
+              </a:ext>
+            </a:extLst>
+          </p:cNvPr>
+          <p:cNvPicPr>
+            <a:picLocks noChangeAspect="1"/>
+          </p:cNvPicPr>
+          <p:nvPr/>
+        </p:nvPicPr>
+        <p:blipFill>
+          <a:blip r:embed="rId2"/>
+          <a:stretch>
+            <a:fillRect/>
+          </a:stretch>
+        </p:blipFill>
+        <p:spPr>
+          <a:xfrm>
+            <a:off x="457200" y="1776642"/>
+            <a:ext cx="8229600" cy="2920562"/>
+          </a:xfrm>
+          <a:prstGeom prst="rect">
+            <a:avLst/>
+          </a:prstGeom>
+        </p:spPr>
+      </p:pic>
+    </p:spTree>
+  </p:cSld>
+  <p:clrMapOvr>
+    <a:masterClrMapping/>
+  </p:clrMapOvr>
+</p:sld>
+</file>
+
+<file path=ppt/slides/slide11.xml><?xml version="1.0" encoding="utf-8"?>
+<p:sld xmlns:a="http://schemas.openxmlformats.org/drawingml/2006/main" xmlns:r="http://schemas.openxmlformats.org/officeDocument/2006/relationships" xmlns:p="http://schemas.openxmlformats.org/presentationml/2006/main">
+  <p:cSld name="Slide 8">
+    <p:bg>
+      <p:bgPr>
+        <a:solidFill>
+          <a:srgbClr val="1E3A8A"/>
+        </a:solidFill>
+        <a:effectLst/>
+      </p:bgPr>
+    </p:bg>
+    <p:spTree>
+      <p:nvGrpSpPr>
+        <p:cNvPr id="1" name=""/>
+        <p:cNvGrpSpPr/>
+        <p:nvPr/>
+      </p:nvGrpSpPr>
+      <p:grpSpPr>
+        <a:xfrm>
+          <a:off x="0" y="0"/>
+          <a:ext cx="0" cy="0"/>
+          <a:chOff x="0" y="0"/>
+          <a:chExt cx="0" cy="0"/>
+        </a:xfrm>
+      </p:grpSpPr>
+      <p:sp>
+        <p:nvSpPr>
+          <p:cNvPr id="2" name="Shape 0"/>
+          <p:cNvSpPr/>
+          <p:nvPr/>
+        </p:nvSpPr>
+        <p:spPr>
+          <a:xfrm>
+            <a:off x="6583680" y="0"/>
+            <a:ext cx="2560320" cy="5143500"/>
+          </a:xfrm>
+          <a:prstGeom prst="rect">
+            <a:avLst/>
+          </a:prstGeom>
+          <a:solidFill>
+            <a:srgbClr val="1E40AF">
+              <a:alpha val="40000"/>
+            </a:srgbClr>
+          </a:solidFill>
+          <a:ln w="12700">
+            <a:solidFill>
+              <a:srgbClr val="1E40AF"/>
+            </a:solidFill>
+            <a:prstDash val="solid"/>
+          </a:ln>
+        </p:spPr>
+        <p:txBody>
+          <a:bodyPr/>
+          <a:lstStyle/>
+          <a:p>
+            <a:endParaRPr lang="en-NL"/>
+          </a:p>
+        </p:txBody>
+      </p:sp>
+      <p:sp>
+        <p:nvSpPr>
+          <p:cNvPr id="3" name="Shape 1"/>
+          <p:cNvSpPr/>
+          <p:nvPr/>
+        </p:nvSpPr>
+        <p:spPr>
+          <a:xfrm>
+            <a:off x="8046720" y="0"/>
+            <a:ext cx="1097280" cy="5143500"/>
+          </a:xfrm>
+          <a:prstGeom prst="rect">
+            <a:avLst/>
+          </a:prstGeom>
+          <a:solidFill>
+            <a:srgbClr val="1D4ED8">
+              <a:alpha val="50000"/>
+            </a:srgbClr>
+          </a:solidFill>
+          <a:ln w="12700">
+            <a:solidFill>
+              <a:srgbClr val="1D4ED8"/>
+            </a:solidFill>
+            <a:prstDash val="solid"/>
+          </a:ln>
+        </p:spPr>
+        <p:txBody>
+          <a:bodyPr/>
+          <a:lstStyle/>
+          <a:p>
+            <a:endParaRPr lang="en-NL"/>
+          </a:p>
+        </p:txBody>
+      </p:sp>
+      <p:sp>
+        <p:nvSpPr>
+          <p:cNvPr id="4" name="Text 2"/>
+          <p:cNvSpPr/>
+          <p:nvPr/>
+        </p:nvSpPr>
+        <p:spPr>
+          <a:xfrm>
+            <a:off x="548640" y="457200"/>
+            <a:ext cx="5486400" cy="411480"/>
+          </a:xfrm>
+          <a:prstGeom prst="rect">
+            <a:avLst/>
+          </a:prstGeom>
+          <a:noFill/>
+          <a:ln/>
+        </p:spPr>
+        <p:txBody>
+          <a:bodyPr wrap="square" lIns="0" tIns="0" rIns="0" bIns="0" rtlCol="0" anchor="ctr"/>
+          <a:lstStyle/>
+          <a:p>
+            <a:pPr marL="0" indent="0">
+              <a:buNone/>
+            </a:pPr>
+            <a:r>
+              <a:rPr lang="en-US" sz="1100" b="1" kern="0" spc="400" dirty="0">
+                <a:solidFill>
+                  <a:srgbClr val="DBEAFE"/>
+                </a:solidFill>
+                <a:latin typeface="Calibri" pitchFamily="34" charset="0"/>
+                <a:ea typeface="Calibri" pitchFamily="34" charset="-122"/>
+                <a:cs typeface="Calibri" pitchFamily="34" charset="-120"/>
+              </a:rPr>
+              <a:t>Tech stack</a:t>
+            </a:r>
+            <a:endParaRPr lang="en-US" sz="1100" dirty="0"/>
+          </a:p>
+        </p:txBody>
+      </p:sp>
+      <p:sp>
+        <p:nvSpPr>
+          <p:cNvPr id="5" name="Text 3"/>
+          <p:cNvSpPr/>
+          <p:nvPr/>
+        </p:nvSpPr>
+        <p:spPr>
+          <a:xfrm>
+            <a:off x="548640" y="960120"/>
+            <a:ext cx="5486400" cy="2011680"/>
+          </a:xfrm>
+          <a:prstGeom prst="rect">
+            <a:avLst/>
+          </a:prstGeom>
+          <a:noFill/>
+          <a:ln/>
+        </p:spPr>
+        <p:txBody>
+          <a:bodyPr wrap="square" lIns="0" tIns="0" rIns="0" bIns="0" rtlCol="0" anchor="ctr"/>
+          <a:lstStyle/>
+          <a:p>
+            <a:pPr marL="342900" indent="-342900">
+              <a:buSzPct val="100000"/>
+              <a:buChar char="•"/>
+            </a:pPr>
+            <a:r>
+              <a:rPr lang="en-US" sz="1300" dirty="0">
+                <a:solidFill>
+                  <a:srgbClr val="FFFFFF"/>
+                </a:solidFill>
+                <a:latin typeface="Calibri" pitchFamily="34" charset="0"/>
+                <a:ea typeface="Calibri" pitchFamily="34" charset="-122"/>
+                <a:cs typeface="Calibri" pitchFamily="34" charset="-120"/>
+              </a:rPr>
+              <a:t>Vue 3 + Vite</a:t>
+            </a:r>
+            <a:endParaRPr lang="en-US" sz="1300" dirty="0"/>
+          </a:p>
+          <a:p>
+            <a:pPr marL="342900" indent="-342900">
+              <a:buSzPct val="100000"/>
+              <a:buChar char="•"/>
+            </a:pPr>
+            <a:r>
+              <a:rPr lang="en-US" sz="1300" dirty="0">
+                <a:solidFill>
+                  <a:srgbClr val="FFFFFF"/>
+                </a:solidFill>
+                <a:latin typeface="Calibri" pitchFamily="34" charset="0"/>
+                <a:ea typeface="Calibri" pitchFamily="34" charset="-122"/>
+                <a:cs typeface="Calibri" pitchFamily="34" charset="-120"/>
+              </a:rPr>
+              <a:t>Pinia · Vue Router</a:t>
+            </a:r>
+            <a:endParaRPr lang="en-US" sz="1300" dirty="0"/>
+          </a:p>
+          <a:p>
+            <a:pPr marL="342900" indent="-342900">
+              <a:buSzPct val="100000"/>
+              <a:buChar char="•"/>
+            </a:pPr>
+            <a:r>
+              <a:rPr lang="en-US" sz="1300" dirty="0">
+                <a:solidFill>
+                  <a:srgbClr val="FFFFFF"/>
+                </a:solidFill>
+                <a:latin typeface="Calibri" pitchFamily="34" charset="0"/>
+                <a:ea typeface="Calibri" pitchFamily="34" charset="-122"/>
+                <a:cs typeface="Calibri" pitchFamily="34" charset="-120"/>
+              </a:rPr>
+              <a:t>TailwindCSS v4</a:t>
+            </a:r>
+            <a:endParaRPr lang="en-US" sz="1300" dirty="0"/>
+          </a:p>
+          <a:p>
+            <a:pPr marL="342900" indent="-342900">
+              <a:buSzPct val="100000"/>
+              <a:buChar char="•"/>
+            </a:pPr>
+            <a:r>
+              <a:rPr lang="en-US" sz="1300" dirty="0">
+                <a:solidFill>
+                  <a:srgbClr val="FFFFFF"/>
+                </a:solidFill>
+                <a:latin typeface="Calibri" pitchFamily="34" charset="0"/>
+                <a:ea typeface="Calibri" pitchFamily="34" charset="-122"/>
+                <a:cs typeface="Calibri" pitchFamily="34" charset="-120"/>
+              </a:rPr>
+              <a:t>JSON dataopslag via Vite-middleware</a:t>
+            </a:r>
+            <a:endParaRPr lang="en-US" sz="1300" dirty="0"/>
+          </a:p>
+          <a:p>
+            <a:pPr marL="342900" indent="-342900">
+              <a:buSzPct val="100000"/>
+              <a:buChar char="•"/>
+            </a:pPr>
+            <a:r>
+              <a:rPr lang="en-US" sz="1300" dirty="0">
+                <a:solidFill>
+                  <a:srgbClr val="FFFFFF"/>
+                </a:solidFill>
+                <a:latin typeface="Calibri" pitchFamily="34" charset="0"/>
+                <a:ea typeface="Calibri" pitchFamily="34" charset="-122"/>
+                <a:cs typeface="Calibri" pitchFamily="34" charset="-120"/>
+              </a:rPr>
+              <a:t>Geen aparte backend</a:t>
+            </a:r>
+            <a:endParaRPr lang="en-US" sz="1300" dirty="0"/>
+          </a:p>
+        </p:txBody>
+      </p:sp>
+      <p:sp>
+        <p:nvSpPr>
+          <p:cNvPr id="6" name="Shape 4"/>
+          <p:cNvSpPr/>
+          <p:nvPr/>
+        </p:nvSpPr>
+        <p:spPr>
+          <a:xfrm>
+            <a:off x="548640" y="3154680"/>
+            <a:ext cx="1645920" cy="1371600"/>
+          </a:xfrm>
+          <a:prstGeom prst="rect">
+            <a:avLst/>
+          </a:prstGeom>
+          <a:solidFill>
+            <a:srgbClr val="1E40AF">
+              <a:alpha val="60000"/>
+            </a:srgbClr>
+          </a:solidFill>
+          <a:ln w="12700">
+            <a:solidFill>
+              <a:srgbClr val="3B82F6"/>
+            </a:solidFill>
+            <a:prstDash val="solid"/>
+          </a:ln>
+        </p:spPr>
+        <p:txBody>
+          <a:bodyPr/>
+          <a:lstStyle/>
+          <a:p>
+            <a:endParaRPr lang="en-NL"/>
+          </a:p>
+        </p:txBody>
+      </p:sp>
+      <p:sp>
+        <p:nvSpPr>
+          <p:cNvPr id="7" name="Text 5"/>
+          <p:cNvSpPr/>
+          <p:nvPr/>
+        </p:nvSpPr>
+        <p:spPr>
+          <a:xfrm>
+            <a:off x="548640" y="3246120"/>
+            <a:ext cx="1645920" cy="685800"/>
+          </a:xfrm>
+          <a:prstGeom prst="rect">
+            <a:avLst/>
+          </a:prstGeom>
+          <a:noFill/>
+          <a:ln/>
+        </p:spPr>
+        <p:txBody>
+          <a:bodyPr wrap="square" lIns="0" tIns="0" rIns="0" bIns="0" rtlCol="0" anchor="ctr"/>
+          <a:lstStyle/>
+          <a:p>
+            <a:pPr marL="0" indent="0" algn="ctr">
+              <a:buNone/>
+            </a:pPr>
+            <a:r>
+              <a:rPr lang="en-US" sz="3600" b="1" dirty="0">
+                <a:solidFill>
+                  <a:srgbClr val="FFFFFF"/>
+                </a:solidFill>
+                <a:latin typeface="Arial Black" pitchFamily="34" charset="0"/>
+                <a:ea typeface="Arial Black" pitchFamily="34" charset="-122"/>
+                <a:cs typeface="Arial Black" pitchFamily="34" charset="-120"/>
+              </a:rPr>
+              <a:t>8</a:t>
+            </a:r>
+            <a:endParaRPr lang="en-US" sz="3600" dirty="0"/>
+          </a:p>
+        </p:txBody>
+      </p:sp>
+      <p:sp>
+        <p:nvSpPr>
+          <p:cNvPr id="8" name="Text 6"/>
+          <p:cNvSpPr/>
+          <p:nvPr/>
+        </p:nvSpPr>
+        <p:spPr>
+          <a:xfrm>
+            <a:off x="548640" y="3931920"/>
+            <a:ext cx="1645920" cy="274320"/>
+          </a:xfrm>
+          <a:prstGeom prst="rect">
+            <a:avLst/>
+          </a:prstGeom>
+          <a:noFill/>
+          <a:ln/>
+        </p:spPr>
+        <p:txBody>
+          <a:bodyPr wrap="square" lIns="0" tIns="0" rIns="0" bIns="0" rtlCol="0" anchor="ctr"/>
+          <a:lstStyle/>
+          <a:p>
+            <a:pPr marL="0" indent="0" algn="ctr">
+              <a:buNone/>
+            </a:pPr>
+            <a:r>
+              <a:rPr lang="en-US" sz="1100" dirty="0">
+                <a:solidFill>
+                  <a:srgbClr val="DBEAFE"/>
+                </a:solidFill>
+                <a:latin typeface="Calibri" pitchFamily="34" charset="0"/>
+                <a:ea typeface="Calibri" pitchFamily="34" charset="-122"/>
+                <a:cs typeface="Calibri" pitchFamily="34" charset="-120"/>
+              </a:rPr>
+              <a:t>modules</a:t>
+            </a:r>
+            <a:endParaRPr lang="en-US" sz="1100" dirty="0"/>
+          </a:p>
+        </p:txBody>
+      </p:sp>
+      <p:sp>
+        <p:nvSpPr>
+          <p:cNvPr id="9" name="Shape 7"/>
+          <p:cNvSpPr/>
+          <p:nvPr/>
+        </p:nvSpPr>
+        <p:spPr>
+          <a:xfrm>
+            <a:off x="2468880" y="3154680"/>
+            <a:ext cx="1645920" cy="1371600"/>
+          </a:xfrm>
+          <a:prstGeom prst="rect">
+            <a:avLst/>
+          </a:prstGeom>
+          <a:solidFill>
+            <a:srgbClr val="1E40AF">
+              <a:alpha val="60000"/>
+            </a:srgbClr>
+          </a:solidFill>
+          <a:ln w="12700">
+            <a:solidFill>
+              <a:srgbClr val="3B82F6"/>
+            </a:solidFill>
+            <a:prstDash val="solid"/>
+          </a:ln>
+        </p:spPr>
+        <p:txBody>
+          <a:bodyPr/>
+          <a:lstStyle/>
+          <a:p>
+            <a:endParaRPr lang="en-NL"/>
+          </a:p>
+        </p:txBody>
+      </p:sp>
+      <p:sp>
+        <p:nvSpPr>
+          <p:cNvPr id="10" name="Text 8"/>
+          <p:cNvSpPr/>
+          <p:nvPr/>
+        </p:nvSpPr>
+        <p:spPr>
+          <a:xfrm>
+            <a:off x="2468880" y="3246120"/>
+            <a:ext cx="1645920" cy="685800"/>
+          </a:xfrm>
+          <a:prstGeom prst="rect">
+            <a:avLst/>
+          </a:prstGeom>
+          <a:noFill/>
+          <a:ln/>
+        </p:spPr>
+        <p:txBody>
+          <a:bodyPr wrap="square" lIns="0" tIns="0" rIns="0" bIns="0" rtlCol="0" anchor="ctr"/>
+          <a:lstStyle/>
+          <a:p>
+            <a:pPr marL="0" indent="0" algn="ctr">
+              <a:buNone/>
+            </a:pPr>
+            <a:r>
+              <a:rPr lang="en-US" sz="3600" b="1" dirty="0">
+                <a:solidFill>
+                  <a:srgbClr val="FFFFFF"/>
+                </a:solidFill>
+                <a:latin typeface="Arial Black" pitchFamily="34" charset="0"/>
+                <a:ea typeface="Arial Black" pitchFamily="34" charset="-122"/>
+                <a:cs typeface="Arial Black" pitchFamily="34" charset="-120"/>
+              </a:rPr>
+              <a:t>9</a:t>
+            </a:r>
+            <a:endParaRPr lang="en-US" sz="3600" dirty="0"/>
+          </a:p>
+        </p:txBody>
+      </p:sp>
+      <p:sp>
+        <p:nvSpPr>
+          <p:cNvPr id="11" name="Text 9"/>
+          <p:cNvSpPr/>
+          <p:nvPr/>
+        </p:nvSpPr>
+        <p:spPr>
+          <a:xfrm>
+            <a:off x="2468880" y="3931920"/>
+            <a:ext cx="1645920" cy="274320"/>
+          </a:xfrm>
+          <a:prstGeom prst="rect">
+            <a:avLst/>
+          </a:prstGeom>
+          <a:noFill/>
+          <a:ln/>
+        </p:spPr>
+        <p:txBody>
+          <a:bodyPr wrap="square" lIns="0" tIns="0" rIns="0" bIns="0" rtlCol="0" anchor="ctr"/>
+          <a:lstStyle/>
+          <a:p>
+            <a:pPr marL="0" indent="0" algn="ctr">
+              <a:buNone/>
+            </a:pPr>
+            <a:r>
+              <a:rPr lang="en-US" sz="1100" dirty="0">
+                <a:solidFill>
+                  <a:srgbClr val="DBEAFE"/>
+                </a:solidFill>
+                <a:latin typeface="Calibri" pitchFamily="34" charset="0"/>
+                <a:ea typeface="Calibri" pitchFamily="34" charset="-122"/>
+                <a:cs typeface="Calibri" pitchFamily="34" charset="-120"/>
+              </a:rPr>
+              <a:t>portefeuilles</a:t>
+            </a:r>
+            <a:endParaRPr lang="en-US" sz="1100" dirty="0"/>
+          </a:p>
+        </p:txBody>
+      </p:sp>
+      <p:sp>
+        <p:nvSpPr>
+          <p:cNvPr id="12" name="Shape 10"/>
+          <p:cNvSpPr/>
+          <p:nvPr/>
+        </p:nvSpPr>
+        <p:spPr>
+          <a:xfrm>
+            <a:off x="4389120" y="3154680"/>
+            <a:ext cx="1645920" cy="1371600"/>
+          </a:xfrm>
+          <a:prstGeom prst="rect">
+            <a:avLst/>
+          </a:prstGeom>
+          <a:solidFill>
+            <a:srgbClr val="1E40AF">
+              <a:alpha val="60000"/>
+            </a:srgbClr>
+          </a:solidFill>
+          <a:ln w="12700">
+            <a:solidFill>
+              <a:srgbClr val="3B82F6"/>
+            </a:solidFill>
+            <a:prstDash val="solid"/>
+          </a:ln>
+        </p:spPr>
+        <p:txBody>
+          <a:bodyPr/>
+          <a:lstStyle/>
+          <a:p>
+            <a:endParaRPr lang="en-NL"/>
+          </a:p>
+        </p:txBody>
+      </p:sp>
+      <p:sp>
+        <p:nvSpPr>
+          <p:cNvPr id="13" name="Text 11"/>
+          <p:cNvSpPr/>
+          <p:nvPr/>
+        </p:nvSpPr>
+        <p:spPr>
+          <a:xfrm>
+            <a:off x="4389120" y="3246120"/>
+            <a:ext cx="1645920" cy="685800"/>
+          </a:xfrm>
+          <a:prstGeom prst="rect">
+            <a:avLst/>
+          </a:prstGeom>
+          <a:noFill/>
+          <a:ln/>
+        </p:spPr>
+        <p:txBody>
+          <a:bodyPr wrap="square" lIns="0" tIns="0" rIns="0" bIns="0" rtlCol="0" anchor="ctr"/>
+          <a:lstStyle/>
+          <a:p>
+            <a:pPr marL="0" indent="0" algn="ctr">
+              <a:buNone/>
+            </a:pPr>
+            <a:r>
+              <a:rPr lang="en-US" sz="3600" b="1" dirty="0">
+                <a:solidFill>
+                  <a:srgbClr val="FFFFFF"/>
+                </a:solidFill>
+                <a:latin typeface="Arial Black" pitchFamily="34" charset="0"/>
+                <a:ea typeface="Arial Black" pitchFamily="34" charset="-122"/>
+                <a:cs typeface="Arial Black" pitchFamily="34" charset="-120"/>
+              </a:rPr>
+              <a:t>101</a:t>
+            </a:r>
+            <a:endParaRPr lang="en-US" sz="3600" dirty="0"/>
+          </a:p>
+        </p:txBody>
+      </p:sp>
+      <p:sp>
+        <p:nvSpPr>
+          <p:cNvPr id="14" name="Text 12"/>
+          <p:cNvSpPr/>
+          <p:nvPr/>
+        </p:nvSpPr>
+        <p:spPr>
+          <a:xfrm>
+            <a:off x="4389120" y="3931920"/>
+            <a:ext cx="1645920" cy="274320"/>
+          </a:xfrm>
+          <a:prstGeom prst="rect">
+            <a:avLst/>
+          </a:prstGeom>
+          <a:noFill/>
+          <a:ln/>
+        </p:spPr>
+        <p:txBody>
+          <a:bodyPr wrap="square" lIns="0" tIns="0" rIns="0" bIns="0" rtlCol="0" anchor="ctr"/>
+          <a:lstStyle/>
+          <a:p>
+            <a:pPr marL="0" indent="0" algn="ctr">
+              <a:buNone/>
+            </a:pPr>
+            <a:r>
+              <a:rPr lang="en-US" sz="1100" dirty="0">
+                <a:solidFill>
+                  <a:srgbClr val="DBEAFE"/>
+                </a:solidFill>
+                <a:latin typeface="Calibri" pitchFamily="34" charset="0"/>
+                <a:ea typeface="Calibri" pitchFamily="34" charset="-122"/>
+                <a:cs typeface="Calibri" pitchFamily="34" charset="-120"/>
+              </a:rPr>
+              <a:t>tests</a:t>
+            </a:r>
+            <a:endParaRPr lang="en-US" sz="1100" dirty="0"/>
+          </a:p>
+        </p:txBody>
+      </p:sp>
+      <p:sp>
+        <p:nvSpPr>
+          <p:cNvPr id="15" name="Text 13"/>
+          <p:cNvSpPr/>
+          <p:nvPr/>
+        </p:nvSpPr>
+        <p:spPr>
+          <a:xfrm>
+            <a:off x="548640" y="4663440"/>
+            <a:ext cx="3657600" cy="274320"/>
+          </a:xfrm>
+          <a:prstGeom prst="rect">
+            <a:avLst/>
+          </a:prstGeom>
+          <a:noFill/>
+          <a:ln/>
+        </p:spPr>
+        <p:txBody>
+          <a:bodyPr wrap="square" lIns="0" tIns="0" rIns="0" bIns="0" rtlCol="0" anchor="ctr"/>
+          <a:lstStyle/>
+          <a:p>
+            <a:pPr marL="0" indent="0" algn="l">
+              <a:buNone/>
+            </a:pPr>
+            <a:r>
+              <a:rPr lang="en-US" sz="1000" i="1" dirty="0">
+                <a:solidFill>
+                  <a:srgbClr val="93C5FD"/>
+                </a:solidFill>
+                <a:latin typeface="Calibri" pitchFamily="34" charset="0"/>
+                <a:ea typeface="Calibri" pitchFamily="34" charset="-122"/>
+                <a:cs typeface="Calibri" pitchFamily="34" charset="-120"/>
+              </a:rPr>
+              <a:t>Blauwdrukbeheer</a:t>
+            </a:r>
+            <a:endParaRPr lang="en-US" sz="1000" dirty="0"/>
+          </a:p>
+        </p:txBody>
+      </p:sp>
+    </p:spTree>
+  </p:cSld>
+  <p:clrMapOvr>
+    <a:masterClrMapping/>
+  </p:clrMapOvr>
+</p:sld>
+</file>
+
 <file path=ppt/slides/slide2.xml><?xml version="1.0" encoding="utf-8"?>
 <p:sld xmlns:a="http://schemas.openxmlformats.org/drawingml/2006/main" xmlns:r="http://schemas.openxmlformats.org/officeDocument/2006/relationships" xmlns:p="http://schemas.openxmlformats.org/presentationml/2006/main">
   <p:cSld name="Slide 2">
@@ -3782,11 +4552,11 @@
 
 <file path=ppt/slides/slide9.xml><?xml version="1.0" encoding="utf-8"?>
 <p:sld xmlns:a="http://schemas.openxmlformats.org/drawingml/2006/main" xmlns:r="http://schemas.openxmlformats.org/officeDocument/2006/relationships" xmlns:p="http://schemas.openxmlformats.org/presentationml/2006/main">
-  <p:cSld name="Slide 8">
+  <p:cSld name="Slide 10">
     <p:bg>
       <p:bgPr>
         <a:solidFill>
-          <a:srgbClr val="1E3A8A"/>
+          <a:srgbClr val="1E293B"/>
         </a:solidFill>
         <a:effectLst/>
       </p:bgPr>
@@ -3807,82 +4577,14 @@
       </p:grpSpPr>
       <p:sp>
         <p:nvSpPr>
-          <p:cNvPr id="2" name="Shape 0"/>
-          <p:cNvSpPr/>
-          <p:nvPr/>
-        </p:nvSpPr>
-        <p:spPr>
-          <a:xfrm>
-            <a:off x="6583680" y="0"/>
-            <a:ext cx="2560320" cy="5143500"/>
-          </a:xfrm>
-          <a:prstGeom prst="rect">
-            <a:avLst/>
-          </a:prstGeom>
-          <a:solidFill>
-            <a:srgbClr val="1E40AF">
-              <a:alpha val="40000"/>
-            </a:srgbClr>
-          </a:solidFill>
-          <a:ln w="12700">
-            <a:solidFill>
-              <a:srgbClr val="1E40AF"/>
-            </a:solidFill>
-            <a:prstDash val="solid"/>
-          </a:ln>
-        </p:spPr>
-        <p:txBody>
-          <a:bodyPr/>
-          <a:lstStyle/>
-          <a:p>
-            <a:endParaRPr lang="en-NL"/>
-          </a:p>
-        </p:txBody>
-      </p:sp>
-      <p:sp>
-        <p:nvSpPr>
-          <p:cNvPr id="3" name="Shape 1"/>
-          <p:cNvSpPr/>
-          <p:nvPr/>
-        </p:nvSpPr>
-        <p:spPr>
-          <a:xfrm>
-            <a:off x="8046720" y="0"/>
-            <a:ext cx="1097280" cy="5143500"/>
-          </a:xfrm>
-          <a:prstGeom prst="rect">
-            <a:avLst/>
-          </a:prstGeom>
-          <a:solidFill>
-            <a:srgbClr val="1D4ED8">
-              <a:alpha val="50000"/>
-            </a:srgbClr>
-          </a:solidFill>
-          <a:ln w="12700">
-            <a:solidFill>
-              <a:srgbClr val="1D4ED8"/>
-            </a:solidFill>
-            <a:prstDash val="solid"/>
-          </a:ln>
-        </p:spPr>
-        <p:txBody>
-          <a:bodyPr/>
-          <a:lstStyle/>
-          <a:p>
-            <a:endParaRPr lang="en-NL"/>
-          </a:p>
-        </p:txBody>
-      </p:sp>
-      <p:sp>
-        <p:nvSpPr>
-          <p:cNvPr id="4" name="Text 2"/>
-          <p:cNvSpPr/>
-          <p:nvPr/>
-        </p:nvSpPr>
-        <p:spPr>
-          <a:xfrm>
-            <a:off x="548640" y="457200"/>
-            <a:ext cx="5486400" cy="411480"/>
+          <p:cNvPr id="2" name="Text 0"/>
+          <p:cNvSpPr/>
+          <p:nvPr/>
+        </p:nvSpPr>
+        <p:spPr>
+          <a:xfrm>
+            <a:off x="457200" y="274320"/>
+            <a:ext cx="8229600" cy="502920"/>
           </a:xfrm>
           <a:prstGeom prst="rect">
             <a:avLst/>
@@ -3894,11 +4596,50 @@
           <a:bodyPr wrap="square" lIns="0" tIns="0" rIns="0" bIns="0" rtlCol="0" anchor="ctr"/>
           <a:lstStyle/>
           <a:p>
-            <a:pPr marL="0" indent="0">
+            <a:pPr marL="0" indent="0" algn="l">
               <a:buNone/>
             </a:pPr>
             <a:r>
-              <a:rPr lang="en-US" sz="1100" b="1" kern="0" spc="400" dirty="0">
+              <a:rPr lang="nl-NL" sz="2600" b="1" dirty="0">
+                <a:solidFill>
+                  <a:srgbClr val="FFFFFF"/>
+                </a:solidFill>
+                <a:latin typeface="Arial Black" pitchFamily="34" charset="0"/>
+                <a:ea typeface="Arial Black" pitchFamily="34" charset="-122"/>
+                <a:cs typeface="Arial Black" pitchFamily="34" charset="-120"/>
+              </a:rPr>
+              <a:t>GitHub synchronisatie</a:t>
+            </a:r>
+            <a:endParaRPr lang="nl-NL" sz="2600" dirty="0"/>
+          </a:p>
+        </p:txBody>
+      </p:sp>
+      <p:sp>
+        <p:nvSpPr>
+          <p:cNvPr id="3" name="Text 1"/>
+          <p:cNvSpPr/>
+          <p:nvPr/>
+        </p:nvSpPr>
+        <p:spPr>
+          <a:xfrm>
+            <a:off x="457200" y="822960"/>
+            <a:ext cx="8229600" cy="365760"/>
+          </a:xfrm>
+          <a:prstGeom prst="rect">
+            <a:avLst/>
+          </a:prstGeom>
+          <a:noFill/>
+          <a:ln/>
+        </p:spPr>
+        <p:txBody>
+          <a:bodyPr wrap="square" lIns="0" tIns="0" rIns="0" bIns="0" rtlCol="0" anchor="ctr"/>
+          <a:lstStyle/>
+          <a:p>
+            <a:pPr marL="0" indent="0" algn="l">
+              <a:buNone/>
+            </a:pPr>
+            <a:r>
+              <a:rPr lang="nl-NL" sz="1200" dirty="0">
                 <a:solidFill>
                   <a:srgbClr val="DBEAFE"/>
                 </a:solidFill>
@@ -3906,499 +4647,102 @@
                 <a:ea typeface="Calibri" pitchFamily="34" charset="-122"/>
                 <a:cs typeface="Calibri" pitchFamily="34" charset="-120"/>
               </a:rPr>
-              <a:t>Tech stack</a:t>
-            </a:r>
-            <a:endParaRPr lang="en-US" sz="1100" dirty="0"/>
-          </a:p>
-        </p:txBody>
-      </p:sp>
-      <p:sp>
-        <p:nvSpPr>
-          <p:cNvPr id="5" name="Text 3"/>
-          <p:cNvSpPr/>
-          <p:nvPr/>
-        </p:nvSpPr>
-        <p:spPr>
-          <a:xfrm>
-            <a:off x="548640" y="960120"/>
-            <a:ext cx="5486400" cy="2011680"/>
-          </a:xfrm>
-          <a:prstGeom prst="rect">
-            <a:avLst/>
-          </a:prstGeom>
-          <a:noFill/>
-          <a:ln/>
-        </p:spPr>
-        <p:txBody>
-          <a:bodyPr wrap="square" lIns="0" tIns="0" rIns="0" bIns="0" rtlCol="0" anchor="ctr"/>
-          <a:lstStyle/>
-          <a:p>
-            <a:pPr marL="342900" indent="-342900">
-              <a:buSzPct val="100000"/>
-              <a:buChar char="•"/>
-            </a:pPr>
-            <a:r>
-              <a:rPr lang="en-US" sz="1300" dirty="0">
-                <a:solidFill>
-                  <a:srgbClr val="FFFFFF"/>
-                </a:solidFill>
-                <a:latin typeface="Calibri" pitchFamily="34" charset="0"/>
-                <a:ea typeface="Calibri" pitchFamily="34" charset="-122"/>
-                <a:cs typeface="Calibri" pitchFamily="34" charset="-120"/>
-              </a:rPr>
-              <a:t>Vue 3 + Vite</a:t>
-            </a:r>
-            <a:endParaRPr lang="en-US" sz="1300" dirty="0"/>
-          </a:p>
-          <a:p>
-            <a:pPr marL="342900" indent="-342900">
-              <a:buSzPct val="100000"/>
-              <a:buChar char="•"/>
-            </a:pPr>
-            <a:r>
-              <a:rPr lang="en-US" sz="1300" dirty="0">
-                <a:solidFill>
-                  <a:srgbClr val="FFFFFF"/>
-                </a:solidFill>
-                <a:latin typeface="Calibri" pitchFamily="34" charset="0"/>
-                <a:ea typeface="Calibri" pitchFamily="34" charset="-122"/>
-                <a:cs typeface="Calibri" pitchFamily="34" charset="-120"/>
-              </a:rPr>
-              <a:t>Pinia · Vue Router</a:t>
-            </a:r>
-            <a:endParaRPr lang="en-US" sz="1300" dirty="0"/>
-          </a:p>
-          <a:p>
-            <a:pPr marL="342900" indent="-342900">
-              <a:buSzPct val="100000"/>
-              <a:buChar char="•"/>
-            </a:pPr>
-            <a:r>
-              <a:rPr lang="en-US" sz="1300" dirty="0">
-                <a:solidFill>
-                  <a:srgbClr val="FFFFFF"/>
-                </a:solidFill>
-                <a:latin typeface="Calibri" pitchFamily="34" charset="0"/>
-                <a:ea typeface="Calibri" pitchFamily="34" charset="-122"/>
-                <a:cs typeface="Calibri" pitchFamily="34" charset="-120"/>
-              </a:rPr>
-              <a:t>TailwindCSS v4</a:t>
-            </a:r>
-            <a:endParaRPr lang="en-US" sz="1300" dirty="0"/>
-          </a:p>
-          <a:p>
-            <a:pPr marL="342900" indent="-342900">
-              <a:buSzPct val="100000"/>
-              <a:buChar char="•"/>
-            </a:pPr>
-            <a:r>
-              <a:rPr lang="en-US" sz="1300" dirty="0">
-                <a:solidFill>
-                  <a:srgbClr val="FFFFFF"/>
-                </a:solidFill>
-                <a:latin typeface="Calibri" pitchFamily="34" charset="0"/>
-                <a:ea typeface="Calibri" pitchFamily="34" charset="-122"/>
-                <a:cs typeface="Calibri" pitchFamily="34" charset="-120"/>
-              </a:rPr>
-              <a:t>JSON dataopslag via Vite-middleware</a:t>
-            </a:r>
-            <a:endParaRPr lang="en-US" sz="1300" dirty="0"/>
-          </a:p>
-          <a:p>
-            <a:pPr marL="342900" indent="-342900">
-              <a:buSzPct val="100000"/>
-              <a:buChar char="•"/>
-            </a:pPr>
-            <a:r>
-              <a:rPr lang="en-US" sz="1300" dirty="0">
-                <a:solidFill>
-                  <a:srgbClr val="FFFFFF"/>
-                </a:solidFill>
-                <a:latin typeface="Calibri" pitchFamily="34" charset="0"/>
-                <a:ea typeface="Calibri" pitchFamily="34" charset="-122"/>
-                <a:cs typeface="Calibri" pitchFamily="34" charset="-120"/>
-              </a:rPr>
-              <a:t>Geen aparte backend</a:t>
-            </a:r>
-            <a:endParaRPr lang="en-US" sz="1300" dirty="0"/>
-          </a:p>
-        </p:txBody>
-      </p:sp>
-      <p:sp>
-        <p:nvSpPr>
-          <p:cNvPr id="6" name="Shape 4"/>
-          <p:cNvSpPr/>
-          <p:nvPr/>
-        </p:nvSpPr>
-        <p:spPr>
-          <a:xfrm>
-            <a:off x="548640" y="3154680"/>
-            <a:ext cx="1645920" cy="1371600"/>
-          </a:xfrm>
-          <a:prstGeom prst="rect">
-            <a:avLst/>
-          </a:prstGeom>
-          <a:solidFill>
-            <a:srgbClr val="1E40AF">
-              <a:alpha val="60000"/>
-            </a:srgbClr>
-          </a:solidFill>
-          <a:ln w="12700">
-            <a:solidFill>
-              <a:srgbClr val="3B82F6"/>
-            </a:solidFill>
-            <a:prstDash val="solid"/>
-          </a:ln>
-        </p:spPr>
-        <p:txBody>
-          <a:bodyPr/>
-          <a:lstStyle/>
-          <a:p>
-            <a:endParaRPr lang="en-NL"/>
-          </a:p>
-        </p:txBody>
-      </p:sp>
-      <p:sp>
-        <p:nvSpPr>
-          <p:cNvPr id="7" name="Text 5"/>
-          <p:cNvSpPr/>
-          <p:nvPr/>
-        </p:nvSpPr>
-        <p:spPr>
-          <a:xfrm>
-            <a:off x="548640" y="3246120"/>
-            <a:ext cx="1645920" cy="685800"/>
-          </a:xfrm>
-          <a:prstGeom prst="rect">
-            <a:avLst/>
-          </a:prstGeom>
-          <a:noFill/>
-          <a:ln/>
-        </p:spPr>
-        <p:txBody>
-          <a:bodyPr wrap="square" lIns="0" tIns="0" rIns="0" bIns="0" rtlCol="0" anchor="ctr"/>
-          <a:lstStyle/>
-          <a:p>
-            <a:pPr marL="0" indent="0" algn="ctr">
-              <a:buNone/>
-            </a:pPr>
-            <a:r>
-              <a:rPr lang="en-US" sz="3600" b="1" dirty="0">
-                <a:solidFill>
-                  <a:srgbClr val="FFFFFF"/>
-                </a:solidFill>
-                <a:latin typeface="Arial Black" pitchFamily="34" charset="0"/>
-                <a:ea typeface="Arial Black" pitchFamily="34" charset="-122"/>
-                <a:cs typeface="Arial Black" pitchFamily="34" charset="-120"/>
-              </a:rPr>
-              <a:t>8</a:t>
-            </a:r>
-            <a:endParaRPr lang="en-US" sz="3600" dirty="0"/>
-          </a:p>
-        </p:txBody>
-      </p:sp>
-      <p:sp>
-        <p:nvSpPr>
-          <p:cNvPr id="8" name="Text 6"/>
-          <p:cNvSpPr/>
-          <p:nvPr/>
-        </p:nvSpPr>
-        <p:spPr>
-          <a:xfrm>
-            <a:off x="548640" y="3931920"/>
-            <a:ext cx="1645920" cy="274320"/>
-          </a:xfrm>
-          <a:prstGeom prst="rect">
-            <a:avLst/>
-          </a:prstGeom>
-          <a:noFill/>
-          <a:ln/>
-        </p:spPr>
-        <p:txBody>
-          <a:bodyPr wrap="square" lIns="0" tIns="0" rIns="0" bIns="0" rtlCol="0" anchor="ctr"/>
-          <a:lstStyle/>
-          <a:p>
-            <a:pPr marL="0" indent="0" algn="ctr">
-              <a:buNone/>
-            </a:pPr>
-            <a:r>
-              <a:rPr lang="en-US" sz="1100" dirty="0">
-                <a:solidFill>
-                  <a:srgbClr val="DBEAFE"/>
-                </a:solidFill>
-                <a:latin typeface="Calibri" pitchFamily="34" charset="0"/>
-                <a:ea typeface="Calibri" pitchFamily="34" charset="-122"/>
-                <a:cs typeface="Calibri" pitchFamily="34" charset="-120"/>
-              </a:rPr>
-              <a:t>modules</a:t>
-            </a:r>
-            <a:endParaRPr lang="en-US" sz="1100" dirty="0"/>
-          </a:p>
-        </p:txBody>
-      </p:sp>
-      <p:sp>
-        <p:nvSpPr>
-          <p:cNvPr id="9" name="Shape 7"/>
-          <p:cNvSpPr/>
-          <p:nvPr/>
-        </p:nvSpPr>
-        <p:spPr>
-          <a:xfrm>
-            <a:off x="2468880" y="3154680"/>
-            <a:ext cx="1645920" cy="1371600"/>
-          </a:xfrm>
-          <a:prstGeom prst="rect">
-            <a:avLst/>
-          </a:prstGeom>
-          <a:solidFill>
-            <a:srgbClr val="1E40AF">
-              <a:alpha val="60000"/>
-            </a:srgbClr>
-          </a:solidFill>
-          <a:ln w="12700">
-            <a:solidFill>
-              <a:srgbClr val="3B82F6"/>
-            </a:solidFill>
-            <a:prstDash val="solid"/>
-          </a:ln>
-        </p:spPr>
-        <p:txBody>
-          <a:bodyPr/>
-          <a:lstStyle/>
-          <a:p>
-            <a:endParaRPr lang="en-NL"/>
-          </a:p>
-        </p:txBody>
-      </p:sp>
-      <p:sp>
-        <p:nvSpPr>
-          <p:cNvPr id="10" name="Text 8"/>
-          <p:cNvSpPr/>
-          <p:nvPr/>
-        </p:nvSpPr>
-        <p:spPr>
-          <a:xfrm>
-            <a:off x="2468880" y="3246120"/>
-            <a:ext cx="1645920" cy="685800"/>
-          </a:xfrm>
-          <a:prstGeom prst="rect">
-            <a:avLst/>
-          </a:prstGeom>
-          <a:noFill/>
-          <a:ln/>
-        </p:spPr>
-        <p:txBody>
-          <a:bodyPr wrap="square" lIns="0" tIns="0" rIns="0" bIns="0" rtlCol="0" anchor="ctr"/>
-          <a:lstStyle/>
-          <a:p>
-            <a:pPr marL="0" indent="0" algn="ctr">
-              <a:buNone/>
-            </a:pPr>
-            <a:r>
-              <a:rPr lang="en-US" sz="3600" b="1" dirty="0">
-                <a:solidFill>
-                  <a:srgbClr val="FFFFFF"/>
-                </a:solidFill>
-                <a:latin typeface="Arial Black" pitchFamily="34" charset="0"/>
-                <a:ea typeface="Arial Black" pitchFamily="34" charset="-122"/>
-                <a:cs typeface="Arial Black" pitchFamily="34" charset="-120"/>
-              </a:rPr>
-              <a:t>9</a:t>
-            </a:r>
-            <a:endParaRPr lang="en-US" sz="3600" dirty="0"/>
-          </a:p>
-        </p:txBody>
-      </p:sp>
-      <p:sp>
-        <p:nvSpPr>
-          <p:cNvPr id="11" name="Text 9"/>
-          <p:cNvSpPr/>
-          <p:nvPr/>
-        </p:nvSpPr>
-        <p:spPr>
-          <a:xfrm>
-            <a:off x="2468880" y="3931920"/>
-            <a:ext cx="1645920" cy="274320"/>
-          </a:xfrm>
-          <a:prstGeom prst="rect">
-            <a:avLst/>
-          </a:prstGeom>
-          <a:noFill/>
-          <a:ln/>
-        </p:spPr>
-        <p:txBody>
-          <a:bodyPr wrap="square" lIns="0" tIns="0" rIns="0" bIns="0" rtlCol="0" anchor="ctr"/>
-          <a:lstStyle/>
-          <a:p>
-            <a:pPr marL="0" indent="0" algn="ctr">
-              <a:buNone/>
-            </a:pPr>
-            <a:r>
-              <a:rPr lang="en-US" sz="1100" dirty="0">
-                <a:solidFill>
-                  <a:srgbClr val="DBEAFE"/>
-                </a:solidFill>
-                <a:latin typeface="Calibri" pitchFamily="34" charset="0"/>
-                <a:ea typeface="Calibri" pitchFamily="34" charset="-122"/>
-                <a:cs typeface="Calibri" pitchFamily="34" charset="-120"/>
-              </a:rPr>
-              <a:t>portefeuilles</a:t>
-            </a:r>
-            <a:endParaRPr lang="en-US" sz="1100" dirty="0"/>
-          </a:p>
-        </p:txBody>
-      </p:sp>
-      <p:sp>
-        <p:nvSpPr>
-          <p:cNvPr id="12" name="Shape 10"/>
-          <p:cNvSpPr/>
-          <p:nvPr/>
-        </p:nvSpPr>
-        <p:spPr>
-          <a:xfrm>
-            <a:off x="4389120" y="3154680"/>
-            <a:ext cx="1645920" cy="1371600"/>
-          </a:xfrm>
-          <a:prstGeom prst="rect">
-            <a:avLst/>
-          </a:prstGeom>
-          <a:solidFill>
-            <a:srgbClr val="1E40AF">
-              <a:alpha val="60000"/>
-            </a:srgbClr>
-          </a:solidFill>
-          <a:ln w="12700">
-            <a:solidFill>
-              <a:srgbClr val="3B82F6"/>
-            </a:solidFill>
-            <a:prstDash val="solid"/>
-          </a:ln>
-        </p:spPr>
-        <p:txBody>
-          <a:bodyPr/>
-          <a:lstStyle/>
-          <a:p>
-            <a:endParaRPr lang="en-NL"/>
-          </a:p>
-        </p:txBody>
-      </p:sp>
-      <p:sp>
-        <p:nvSpPr>
-          <p:cNvPr id="13" name="Text 11"/>
-          <p:cNvSpPr/>
-          <p:nvPr/>
-        </p:nvSpPr>
-        <p:spPr>
-          <a:xfrm>
-            <a:off x="4389120" y="3246120"/>
-            <a:ext cx="1645920" cy="685800"/>
-          </a:xfrm>
-          <a:prstGeom prst="rect">
-            <a:avLst/>
-          </a:prstGeom>
-          <a:noFill/>
-          <a:ln/>
-        </p:spPr>
-        <p:txBody>
-          <a:bodyPr wrap="square" lIns="0" tIns="0" rIns="0" bIns="0" rtlCol="0" anchor="ctr"/>
-          <a:lstStyle/>
-          <a:p>
-            <a:pPr marL="0" indent="0" algn="ctr">
-              <a:buNone/>
-            </a:pPr>
-            <a:r>
-              <a:rPr lang="en-US" sz="3600" b="1" dirty="0">
-                <a:solidFill>
-                  <a:srgbClr val="FFFFFF"/>
-                </a:solidFill>
-                <a:latin typeface="Arial Black" pitchFamily="34" charset="0"/>
-                <a:ea typeface="Arial Black" pitchFamily="34" charset="-122"/>
-                <a:cs typeface="Arial Black" pitchFamily="34" charset="-120"/>
-              </a:rPr>
-              <a:t>101</a:t>
-            </a:r>
-            <a:endParaRPr lang="en-US" sz="3600" dirty="0"/>
-          </a:p>
-        </p:txBody>
-      </p:sp>
-      <p:sp>
-        <p:nvSpPr>
-          <p:cNvPr id="14" name="Text 12"/>
-          <p:cNvSpPr/>
-          <p:nvPr/>
-        </p:nvSpPr>
-        <p:spPr>
-          <a:xfrm>
-            <a:off x="4389120" y="3931920"/>
-            <a:ext cx="1645920" cy="274320"/>
-          </a:xfrm>
-          <a:prstGeom prst="rect">
-            <a:avLst/>
-          </a:prstGeom>
-          <a:noFill/>
-          <a:ln/>
-        </p:spPr>
-        <p:txBody>
-          <a:bodyPr wrap="square" lIns="0" tIns="0" rIns="0" bIns="0" rtlCol="0" anchor="ctr"/>
-          <a:lstStyle/>
-          <a:p>
-            <a:pPr marL="0" indent="0" algn="ctr">
-              <a:buNone/>
-            </a:pPr>
-            <a:r>
-              <a:rPr lang="en-US" sz="1100" dirty="0">
-                <a:solidFill>
-                  <a:srgbClr val="DBEAFE"/>
-                </a:solidFill>
-                <a:latin typeface="Calibri" pitchFamily="34" charset="0"/>
-                <a:ea typeface="Calibri" pitchFamily="34" charset="-122"/>
-                <a:cs typeface="Calibri" pitchFamily="34" charset="-120"/>
-              </a:rPr>
-              <a:t>tests</a:t>
-            </a:r>
-            <a:endParaRPr lang="en-US" sz="1100" dirty="0"/>
-          </a:p>
-        </p:txBody>
-      </p:sp>
-      <p:sp>
-        <p:nvSpPr>
-          <p:cNvPr id="15" name="Text 13"/>
-          <p:cNvSpPr/>
-          <p:nvPr/>
-        </p:nvSpPr>
-        <p:spPr>
-          <a:xfrm>
-            <a:off x="548640" y="4663440"/>
-            <a:ext cx="3657600" cy="274320"/>
-          </a:xfrm>
-          <a:prstGeom prst="rect">
-            <a:avLst/>
-          </a:prstGeom>
-          <a:noFill/>
-          <a:ln/>
-        </p:spPr>
-        <p:txBody>
-          <a:bodyPr wrap="square" lIns="0" tIns="0" rIns="0" bIns="0" rtlCol="0" anchor="ctr"/>
-          <a:lstStyle/>
-          <a:p>
-            <a:pPr marL="0" indent="0" algn="l">
-              <a:buNone/>
-            </a:pPr>
-            <a:r>
-              <a:rPr lang="en-US" sz="1000" i="1" dirty="0">
-                <a:solidFill>
-                  <a:srgbClr val="93C5FD"/>
-                </a:solidFill>
-                <a:latin typeface="Calibri" pitchFamily="34" charset="0"/>
-                <a:ea typeface="Calibri" pitchFamily="34" charset="-122"/>
-                <a:cs typeface="Calibri" pitchFamily="34" charset="-120"/>
-              </a:rPr>
-              <a:t>Blauwdrukbeheer</a:t>
-            </a:r>
-            <a:endParaRPr lang="en-US" sz="1000" dirty="0"/>
-          </a:p>
-        </p:txBody>
-      </p:sp>
+              <a:t>Wijzigingen worden bijgehouden (dirty tracking) en via een feature branch + pull request gepusht naar de data-repository — inclusief gegenereerde PDFs.</a:t>
+            </a:r>
+            <a:endParaRPr lang="nl-NL" sz="1200" dirty="0"/>
+          </a:p>
+        </p:txBody>
+      </p:sp>
+      <p:pic>
+        <p:nvPicPr>
+          <p:cNvPr id="6" name="Picture 5">
+            <a:extLst>
+              <a:ext uri="{FF2B5EF4-FFF2-40B4-BE49-F238E27FC236}">
+                <a16:creationId xmlns:a16="http://schemas.microsoft.com/office/drawing/2014/main" id="{718AFB01-4D1B-BB1F-D4CB-EFD6C9B92D34}"/>
+              </a:ext>
+            </a:extLst>
+          </p:cNvPr>
+          <p:cNvPicPr>
+            <a:picLocks noChangeAspect="1"/>
+          </p:cNvPicPr>
+          <p:nvPr/>
+        </p:nvPicPr>
+        <p:blipFill>
+          <a:blip r:embed="rId2"/>
+          <a:stretch>
+            <a:fillRect/>
+          </a:stretch>
+        </p:blipFill>
+        <p:spPr>
+          <a:xfrm>
+            <a:off x="4424836" y="3354894"/>
+            <a:ext cx="4477291" cy="1608675"/>
+          </a:xfrm>
+          <a:prstGeom prst="rect">
+            <a:avLst/>
+          </a:prstGeom>
+        </p:spPr>
+      </p:pic>
+      <p:pic>
+        <p:nvPicPr>
+          <p:cNvPr id="8" name="Picture 7">
+            <a:extLst>
+              <a:ext uri="{FF2B5EF4-FFF2-40B4-BE49-F238E27FC236}">
+                <a16:creationId xmlns:a16="http://schemas.microsoft.com/office/drawing/2014/main" id="{C41FD7F0-79DA-9B82-F8E3-05F4A78FEE59}"/>
+              </a:ext>
+            </a:extLst>
+          </p:cNvPr>
+          <p:cNvPicPr>
+            <a:picLocks noChangeAspect="1"/>
+          </p:cNvPicPr>
+          <p:nvPr/>
+        </p:nvPicPr>
+        <p:blipFill>
+          <a:blip r:embed="rId3"/>
+          <a:stretch>
+            <a:fillRect/>
+          </a:stretch>
+        </p:blipFill>
+        <p:spPr>
+          <a:xfrm>
+            <a:off x="159282" y="1711505"/>
+            <a:ext cx="4477291" cy="2666531"/>
+          </a:xfrm>
+          <a:prstGeom prst="rect">
+            <a:avLst/>
+          </a:prstGeom>
+        </p:spPr>
+      </p:pic>
+      <p:pic>
+        <p:nvPicPr>
+          <p:cNvPr id="10" name="Picture 9">
+            <a:extLst>
+              <a:ext uri="{FF2B5EF4-FFF2-40B4-BE49-F238E27FC236}">
+                <a16:creationId xmlns:a16="http://schemas.microsoft.com/office/drawing/2014/main" id="{9DB4049F-A8EB-C4B5-2032-D7B527A1F455}"/>
+              </a:ext>
+            </a:extLst>
+          </p:cNvPr>
+          <p:cNvPicPr>
+            <a:picLocks noChangeAspect="1"/>
+          </p:cNvPicPr>
+          <p:nvPr/>
+        </p:nvPicPr>
+        <p:blipFill>
+          <a:blip r:embed="rId4"/>
+          <a:stretch>
+            <a:fillRect/>
+          </a:stretch>
+        </p:blipFill>
+        <p:spPr>
+          <a:xfrm>
+            <a:off x="3433105" y="1188720"/>
+            <a:ext cx="4424836" cy="2025725"/>
+          </a:xfrm>
+          <a:prstGeom prst="rect">
+            <a:avLst/>
+          </a:prstGeom>
+        </p:spPr>
+      </p:pic>
     </p:spTree>
   </p:cSld>
   <p:clrMapOvr>

</xml_diff>

<commit_message>
Extra slide met screenshot
</commit_message>
<xml_diff>
--- a/Blauwdrukbeheer-demo.pptx
+++ b/Blauwdrukbeheer-demo.pptx
@@ -5,7 +5,7 @@
     <p:sldMasterId id="2147483648" r:id="rId1"/>
   </p:sldMasterIdLst>
   <p:notesMasterIdLst>
-    <p:notesMasterId r:id="rId13"/>
+    <p:notesMasterId r:id="rId14"/>
   </p:notesMasterIdLst>
   <p:sldIdLst>
     <p:sldId id="256" r:id="rId2"/>
@@ -17,8 +17,9 @@
     <p:sldId id="261" r:id="rId8"/>
     <p:sldId id="262" r:id="rId9"/>
     <p:sldId id="265" r:id="rId10"/>
-    <p:sldId id="266" r:id="rId11"/>
-    <p:sldId id="263" r:id="rId12"/>
+    <p:sldId id="267" r:id="rId11"/>
+    <p:sldId id="266" r:id="rId12"/>
+    <p:sldId id="263" r:id="rId13"/>
   </p:sldIdLst>
   <p:sldSz cx="9144000" cy="5143500" type="screen16x9"/>
   <p:notesSz cx="5143500" cy="9144000"/>
@@ -1008,7 +1009,7 @@
           <a:p>
             <a:fld id="{F7021451-1387-4CA6-816F-3879F97B5CBC}" type="slidenum">
               <a:rPr lang="en-US"/>
-              <a:t>11</a:t>
+              <a:t>12</a:t>
             </a:fld>
             <a:endParaRPr lang="en-US"/>
           </a:p>
@@ -1664,6 +1665,230 @@
 
 <file path=ppt/slides/slide10.xml><?xml version="1.0" encoding="utf-8"?>
 <p:sld xmlns:a="http://schemas.openxmlformats.org/drawingml/2006/main" xmlns:r="http://schemas.openxmlformats.org/officeDocument/2006/relationships" xmlns:p="http://schemas.openxmlformats.org/presentationml/2006/main">
+  <p:cSld>
+    <p:bg>
+      <p:bgPr>
+        <a:solidFill>
+          <a:srgbClr val="1E293B"/>
+        </a:solidFill>
+        <a:effectLst/>
+      </p:bgPr>
+    </p:bg>
+    <p:spTree>
+      <p:nvGrpSpPr>
+        <p:cNvPr id="1" name="">
+          <a:extLst>
+            <a:ext uri="{FF2B5EF4-FFF2-40B4-BE49-F238E27FC236}">
+              <a16:creationId xmlns:a16="http://schemas.microsoft.com/office/drawing/2014/main" id="{D0420E7C-B032-6930-AEE2-01281C04F4D0}"/>
+            </a:ext>
+          </a:extLst>
+        </p:cNvPr>
+        <p:cNvGrpSpPr/>
+        <p:nvPr/>
+      </p:nvGrpSpPr>
+      <p:grpSpPr>
+        <a:xfrm>
+          <a:off x="0" y="0"/>
+          <a:ext cx="0" cy="0"/>
+          <a:chOff x="0" y="0"/>
+          <a:chExt cx="0" cy="0"/>
+        </a:xfrm>
+      </p:grpSpPr>
+      <p:sp>
+        <p:nvSpPr>
+          <p:cNvPr id="2" name="Text 0">
+            <a:extLst>
+              <a:ext uri="{FF2B5EF4-FFF2-40B4-BE49-F238E27FC236}">
+                <a16:creationId xmlns:a16="http://schemas.microsoft.com/office/drawing/2014/main" id="{C02805A9-5FAB-60BB-5530-427A61212EDA}"/>
+              </a:ext>
+            </a:extLst>
+          </p:cNvPr>
+          <p:cNvSpPr/>
+          <p:nvPr/>
+        </p:nvSpPr>
+        <p:spPr>
+          <a:xfrm>
+            <a:off x="457200" y="274320"/>
+            <a:ext cx="8229600" cy="502920"/>
+          </a:xfrm>
+          <a:prstGeom prst="rect">
+            <a:avLst/>
+          </a:prstGeom>
+          <a:noFill/>
+          <a:ln/>
+        </p:spPr>
+        <p:txBody>
+          <a:bodyPr wrap="square" lIns="0" tIns="0" rIns="0" bIns="0" rtlCol="0" anchor="ctr"/>
+          <a:lstStyle/>
+          <a:p>
+            <a:pPr marL="0" indent="0" algn="l">
+              <a:buNone/>
+            </a:pPr>
+            <a:r>
+              <a:rPr lang="nl-NL" sz="2600" b="1" dirty="0">
+                <a:solidFill>
+                  <a:srgbClr val="FFFFFF"/>
+                </a:solidFill>
+                <a:latin typeface="Arial Black" pitchFamily="34" charset="0"/>
+                <a:ea typeface="Arial Black" pitchFamily="34" charset="-122"/>
+                <a:cs typeface="Arial Black" pitchFamily="34" charset="-120"/>
+              </a:rPr>
+              <a:t>GitHub synchronisatie</a:t>
+            </a:r>
+            <a:endParaRPr lang="nl-NL" sz="2600" dirty="0"/>
+          </a:p>
+        </p:txBody>
+      </p:sp>
+      <p:sp>
+        <p:nvSpPr>
+          <p:cNvPr id="3" name="Text 1">
+            <a:extLst>
+              <a:ext uri="{FF2B5EF4-FFF2-40B4-BE49-F238E27FC236}">
+                <a16:creationId xmlns:a16="http://schemas.microsoft.com/office/drawing/2014/main" id="{3D573CCC-5601-1A3E-2D5E-74808D5AB7E3}"/>
+              </a:ext>
+            </a:extLst>
+          </p:cNvPr>
+          <p:cNvSpPr/>
+          <p:nvPr/>
+        </p:nvSpPr>
+        <p:spPr>
+          <a:xfrm>
+            <a:off x="457200" y="822960"/>
+            <a:ext cx="8229600" cy="365760"/>
+          </a:xfrm>
+          <a:prstGeom prst="rect">
+            <a:avLst/>
+          </a:prstGeom>
+          <a:noFill/>
+          <a:ln/>
+        </p:spPr>
+        <p:txBody>
+          <a:bodyPr wrap="square" lIns="0" tIns="0" rIns="0" bIns="0" rtlCol="0" anchor="ctr"/>
+          <a:lstStyle/>
+          <a:p>
+            <a:pPr marL="0" indent="0" algn="l">
+              <a:buNone/>
+            </a:pPr>
+            <a:r>
+              <a:rPr lang="nl-NL" sz="1200" dirty="0">
+                <a:solidFill>
+                  <a:srgbClr val="DBEAFE"/>
+                </a:solidFill>
+                <a:latin typeface="Calibri" pitchFamily="34" charset="0"/>
+                <a:ea typeface="Calibri" pitchFamily="34" charset="-122"/>
+                <a:cs typeface="Calibri" pitchFamily="34" charset="-120"/>
+              </a:rPr>
+              <a:t>Wijzigingen worden bijgehouden (dirty tracking) en via een feature branch + pull request gepusht naar de data-repository — inclusief gegenereerde PDFs.</a:t>
+            </a:r>
+            <a:endParaRPr lang="nl-NL" sz="1200" dirty="0"/>
+          </a:p>
+        </p:txBody>
+      </p:sp>
+      <p:pic>
+        <p:nvPicPr>
+          <p:cNvPr id="6" name="Picture 5">
+            <a:extLst>
+              <a:ext uri="{FF2B5EF4-FFF2-40B4-BE49-F238E27FC236}">
+                <a16:creationId xmlns:a16="http://schemas.microsoft.com/office/drawing/2014/main" id="{974A9B8E-A001-6E5B-2583-3D6E7BD32AD3}"/>
+              </a:ext>
+            </a:extLst>
+          </p:cNvPr>
+          <p:cNvPicPr>
+            <a:picLocks noChangeAspect="1"/>
+          </p:cNvPicPr>
+          <p:nvPr/>
+        </p:nvPicPr>
+        <p:blipFill>
+          <a:blip r:embed="rId2"/>
+          <a:stretch>
+            <a:fillRect/>
+          </a:stretch>
+        </p:blipFill>
+        <p:spPr>
+          <a:xfrm>
+            <a:off x="4424836" y="3354894"/>
+            <a:ext cx="4477291" cy="1608675"/>
+          </a:xfrm>
+          <a:prstGeom prst="rect">
+            <a:avLst/>
+          </a:prstGeom>
+        </p:spPr>
+      </p:pic>
+      <p:pic>
+        <p:nvPicPr>
+          <p:cNvPr id="8" name="Picture 7">
+            <a:extLst>
+              <a:ext uri="{FF2B5EF4-FFF2-40B4-BE49-F238E27FC236}">
+                <a16:creationId xmlns:a16="http://schemas.microsoft.com/office/drawing/2014/main" id="{2F08390D-3071-998A-F5DC-A713FA605568}"/>
+              </a:ext>
+            </a:extLst>
+          </p:cNvPr>
+          <p:cNvPicPr>
+            <a:picLocks noChangeAspect="1"/>
+          </p:cNvPicPr>
+          <p:nvPr/>
+        </p:nvPicPr>
+        <p:blipFill>
+          <a:blip r:embed="rId3"/>
+          <a:stretch>
+            <a:fillRect/>
+          </a:stretch>
+        </p:blipFill>
+        <p:spPr>
+          <a:xfrm>
+            <a:off x="159282" y="1711505"/>
+            <a:ext cx="4477291" cy="2666531"/>
+          </a:xfrm>
+          <a:prstGeom prst="rect">
+            <a:avLst/>
+          </a:prstGeom>
+        </p:spPr>
+      </p:pic>
+      <p:pic>
+        <p:nvPicPr>
+          <p:cNvPr id="10" name="Picture 9">
+            <a:extLst>
+              <a:ext uri="{FF2B5EF4-FFF2-40B4-BE49-F238E27FC236}">
+                <a16:creationId xmlns:a16="http://schemas.microsoft.com/office/drawing/2014/main" id="{BD1510E7-48DC-4DD5-7A1D-AE9D388AA7C1}"/>
+              </a:ext>
+            </a:extLst>
+          </p:cNvPr>
+          <p:cNvPicPr>
+            <a:picLocks noChangeAspect="1"/>
+          </p:cNvPicPr>
+          <p:nvPr/>
+        </p:nvPicPr>
+        <p:blipFill>
+          <a:blip r:embed="rId4"/>
+          <a:stretch>
+            <a:fillRect/>
+          </a:stretch>
+        </p:blipFill>
+        <p:spPr>
+          <a:xfrm>
+            <a:off x="3433105" y="1188720"/>
+            <a:ext cx="4424836" cy="2025725"/>
+          </a:xfrm>
+          <a:prstGeom prst="rect">
+            <a:avLst/>
+          </a:prstGeom>
+        </p:spPr>
+      </p:pic>
+    </p:spTree>
+    <p:extLst>
+      <p:ext uri="{BB962C8B-B14F-4D97-AF65-F5344CB8AC3E}">
+        <p14:creationId xmlns:p14="http://schemas.microsoft.com/office/powerpoint/2010/main" val="895321663"/>
+      </p:ext>
+    </p:extLst>
+  </p:cSld>
+  <p:clrMapOvr>
+    <a:masterClrMapping/>
+  </p:clrMapOvr>
+</p:sld>
+</file>
+
+<file path=ppt/slides/slide11.xml><?xml version="1.0" encoding="utf-8"?>
+<p:sld xmlns:a="http://schemas.openxmlformats.org/drawingml/2006/main" xmlns:r="http://schemas.openxmlformats.org/officeDocument/2006/relationships" xmlns:p="http://schemas.openxmlformats.org/presentationml/2006/main">
   <p:cSld name="Slide 11">
     <p:bg>
       <p:bgPr>
@@ -1803,7 +2028,7 @@
 </p:sld>
 </file>
 
-<file path=ppt/slides/slide11.xml><?xml version="1.0" encoding="utf-8"?>
+<file path=ppt/slides/slide12.xml><?xml version="1.0" encoding="utf-8"?>
 <p:sld xmlns:a="http://schemas.openxmlformats.org/drawingml/2006/main" xmlns:r="http://schemas.openxmlformats.org/officeDocument/2006/relationships" xmlns:p="http://schemas.openxmlformats.org/presentationml/2006/main">
   <p:cSld name="Slide 8">
     <p:bg>
@@ -4655,10 +4880,10 @@
       </p:sp>
       <p:pic>
         <p:nvPicPr>
-          <p:cNvPr id="6" name="Picture 5">
+          <p:cNvPr id="5" name="Picture 4">
             <a:extLst>
               <a:ext uri="{FF2B5EF4-FFF2-40B4-BE49-F238E27FC236}">
-                <a16:creationId xmlns:a16="http://schemas.microsoft.com/office/drawing/2014/main" id="{718AFB01-4D1B-BB1F-D4CB-EFD6C9B92D34}"/>
+                <a16:creationId xmlns:a16="http://schemas.microsoft.com/office/drawing/2014/main" id="{69140018-3F78-7CE9-1D8A-0BB8CF556CAB}"/>
               </a:ext>
             </a:extLst>
           </p:cNvPr>
@@ -4675,68 +4900,8 @@
         </p:blipFill>
         <p:spPr>
           <a:xfrm>
-            <a:off x="4424836" y="3354894"/>
-            <a:ext cx="4477291" cy="1608675"/>
-          </a:xfrm>
-          <a:prstGeom prst="rect">
-            <a:avLst/>
-          </a:prstGeom>
-        </p:spPr>
-      </p:pic>
-      <p:pic>
-        <p:nvPicPr>
-          <p:cNvPr id="8" name="Picture 7">
-            <a:extLst>
-              <a:ext uri="{FF2B5EF4-FFF2-40B4-BE49-F238E27FC236}">
-                <a16:creationId xmlns:a16="http://schemas.microsoft.com/office/drawing/2014/main" id="{C41FD7F0-79DA-9B82-F8E3-05F4A78FEE59}"/>
-              </a:ext>
-            </a:extLst>
-          </p:cNvPr>
-          <p:cNvPicPr>
-            <a:picLocks noChangeAspect="1"/>
-          </p:cNvPicPr>
-          <p:nvPr/>
-        </p:nvPicPr>
-        <p:blipFill>
-          <a:blip r:embed="rId3"/>
-          <a:stretch>
-            <a:fillRect/>
-          </a:stretch>
-        </p:blipFill>
-        <p:spPr>
-          <a:xfrm>
-            <a:off x="159282" y="1711505"/>
-            <a:ext cx="4477291" cy="2666531"/>
-          </a:xfrm>
-          <a:prstGeom prst="rect">
-            <a:avLst/>
-          </a:prstGeom>
-        </p:spPr>
-      </p:pic>
-      <p:pic>
-        <p:nvPicPr>
-          <p:cNvPr id="10" name="Picture 9">
-            <a:extLst>
-              <a:ext uri="{FF2B5EF4-FFF2-40B4-BE49-F238E27FC236}">
-                <a16:creationId xmlns:a16="http://schemas.microsoft.com/office/drawing/2014/main" id="{9DB4049F-A8EB-C4B5-2032-D7B527A1F455}"/>
-              </a:ext>
-            </a:extLst>
-          </p:cNvPr>
-          <p:cNvPicPr>
-            <a:picLocks noChangeAspect="1"/>
-          </p:cNvPicPr>
-          <p:nvPr/>
-        </p:nvPicPr>
-        <p:blipFill>
-          <a:blip r:embed="rId4"/>
-          <a:stretch>
-            <a:fillRect/>
-          </a:stretch>
-        </p:blipFill>
-        <p:spPr>
-          <a:xfrm>
-            <a:off x="3433105" y="1188720"/>
-            <a:ext cx="4424836" cy="2025725"/>
+            <a:off x="1532573" y="1281949"/>
+            <a:ext cx="6078853" cy="3322930"/>
           </a:xfrm>
           <a:prstGeom prst="rect">
             <a:avLst/>

</xml_diff>